<commit_message>
modified:   README.md         modified:   app.py         modified:   docs/presentation.pptx         modified:   docs/project_report.docx         modified:   docs/user_manual.pdf
</commit_message>
<xml_diff>
--- a/docs/presentation.pptx
+++ b/docs/presentation.pptx
@@ -5807,7 +5807,7 @@
                   <a:srgbClr val="FFFFFF"/>
                 </a:solidFill>
               </a:rPr>
-              <a:t>SkyGuard AI</a:t>
+              <a:t>Agentic UAV Mission Planning and Safety Compliance Assistant</a:t>
             </a:r>
           </a:p>
         </p:txBody>
@@ -8080,50 +8080,32 @@
           <a:p>
             <a:pPr algn="l"/>
             <a:r>
-              <a:rPr sz="1700" b="0" dirty="0">
-                <a:solidFill>
-                  <a:srgbClr val="E2E8F0"/>
-                </a:solidFill>
-              </a:rPr>
-              <a:t>[OK]  All 7 safety rules enforced with physics-based validation
-[OK]  Shapely line-segment </a:t>
-            </a:r>
-            <a:r>
-              <a:rPr sz="1700" b="0" dirty="0" err="1">
-                <a:solidFill>
-                  <a:srgbClr val="E2E8F0"/>
-                </a:solidFill>
-              </a:rPr>
-              <a:t>geofence</a:t>
-            </a:r>
-            <a:r>
-              <a:rPr sz="1700" b="0">
-                <a:solidFill>
-                  <a:srgbClr val="E2E8F0"/>
-                </a:solidFill>
-              </a:rPr>
-              <a:t> checks (not just point checks)
-[OK]  Normal-vector boundary correction with exact 15 m clearance
-[OK]  Multi-stage battery model replaces linear heuristic
-[OK]  QGC .plan export for real controller compatibility
-[OK]  9 / 9 unit tests passing  -  Full documentation package
-</a:t>
-            </a:r>
-            <a:r>
-              <a:rPr sz="1700" b="0" dirty="0" err="1">
-                <a:solidFill>
-                  <a:srgbClr val="E2E8F0"/>
-                </a:solidFill>
-              </a:rPr>
-              <a:t>SkyGuard</a:t>
-            </a:r>
-            <a:r>
-              <a:rPr sz="1700" b="0" dirty="0">
-                <a:solidFill>
-                  <a:srgbClr val="E2E8F0"/>
-                </a:solidFill>
-              </a:rPr>
-              <a:t> AI delivers a complete, safe, and deployable UAV mission planning system.</a:t>
+              <a:t>[OK]  All 7 safety rules enforced with physics-based validation</a:t>
+            </a:r>
+            <a:br/>
+            <a:r>
+              <a:t>[OK]  Shapely line-segment geofence checks (not just point checks)</a:t>
+            </a:r>
+            <a:br/>
+            <a:r>
+              <a:t>[OK]  Normal-vector boundary correction with exact 15 m clearance</a:t>
+            </a:r>
+            <a:br/>
+            <a:r>
+              <a:t>[OK]  Multi-stage battery model replaces linear heuristic</a:t>
+            </a:r>
+            <a:br/>
+            <a:r>
+              <a:t>[OK]  QGC .plan export for real controller compatibility</a:t>
+            </a:r>
+            <a:br/>
+            <a:r>
+              <a:t>[OK]  9 / 9 unit tests passing  -  Full documentation package</a:t>
+            </a:r>
+            <a:br/>
+            <a:br/>
+            <a:r>
+              <a:t>Agentic UAV Mission Planning and Safety Compliance Assistant delivers a complete, safe, and deployable UAV mission planning system.</a:t>
             </a:r>
           </a:p>
         </p:txBody>

</xml_diff>

<commit_message>
modified:   app.py         modified:   docs/presentation.pptx         modified:   docs/project_report.docx
</commit_message>
<xml_diff>
--- a/docs/presentation.pptx
+++ b/docs/presentation.pptx
@@ -5699,7 +5699,7 @@
         <p:spPr>
           <a:xfrm>
             <a:off x="0" y="0"/>
-            <a:ext cx="12188952" cy="457200"/>
+            <a:ext cx="12188952" cy="162560"/>
           </a:xfrm>
           <a:prstGeom prst="rect">
             <a:avLst/>
@@ -5802,7 +5802,7 @@
           <a:p>
             <a:pPr algn="l"/>
             <a:r>
-              <a:rPr sz="4400" b="1">
+              <a:rPr sz="4400" b="1" dirty="0">
                 <a:solidFill>
                   <a:srgbClr val="FFFFFF"/>
                 </a:solidFill>
@@ -8103,6 +8103,9 @@
               <a:t>[OK]  9 / 9 unit tests passing  -  Full documentation package</a:t>
             </a:r>
             <a:br/>
+            <a:r>
+              <a:t/>
+            </a:r>
             <a:br/>
             <a:r>
               <a:t>Agentic UAV Mission Planning and Safety Compliance Assistant delivers a complete, safe, and deployable UAV mission planning system.</a:t>

</xml_diff>